<commit_message>
Reorganiza a faixa de baixo da pagina 5
Proximos passos vai para a coluna vazia e o fechamento do relatorio ocupa
a ultima coluna, no lugar da linha de largura inteira.

Co-Authored-By: Claude Opus 5 <noreply@anthropic.com>
Claude-Session: https://claude.ai/code/session_015sjcnKxeY4LRuFtZcg77AJ
</commit_message>
<xml_diff>
--- a/Relatório/Drafts/KAIROSv2_p5.pptx
+++ b/Relatório/Drafts/KAIROSv2_p5.pptx
@@ -302,7 +302,7 @@
           <a:p>
             <a:fld id="{5BCAD085-E8A6-8845-BD4E-CB4CCA059FC4}" type="datetimeFigureOut">
               <a:rPr lang="en-US" smtClean="0"/>
-              <a:t>8/15/2026</a:t>
+              <a:t>8/16/2026</a:t>
             </a:fld>
             <a:endParaRPr lang="en-US"/>
           </a:p>
@@ -470,7 +470,7 @@
           <a:p>
             <a:fld id="{5BCAD085-E8A6-8845-BD4E-CB4CCA059FC4}" type="datetimeFigureOut">
               <a:rPr lang="en-US" smtClean="0"/>
-              <a:t>8/15/2026</a:t>
+              <a:t>8/16/2026</a:t>
             </a:fld>
             <a:endParaRPr lang="en-US"/>
           </a:p>
@@ -648,7 +648,7 @@
           <a:p>
             <a:fld id="{5BCAD085-E8A6-8845-BD4E-CB4CCA059FC4}" type="datetimeFigureOut">
               <a:rPr lang="en-US" smtClean="0"/>
-              <a:t>8/15/2026</a:t>
+              <a:t>8/16/2026</a:t>
             </a:fld>
             <a:endParaRPr lang="en-US"/>
           </a:p>
@@ -816,7 +816,7 @@
           <a:p>
             <a:fld id="{5BCAD085-E8A6-8845-BD4E-CB4CCA059FC4}" type="datetimeFigureOut">
               <a:rPr lang="en-US" smtClean="0"/>
-              <a:t>8/15/2026</a:t>
+              <a:t>8/16/2026</a:t>
             </a:fld>
             <a:endParaRPr lang="en-US"/>
           </a:p>
@@ -1061,7 +1061,7 @@
           <a:p>
             <a:fld id="{5BCAD085-E8A6-8845-BD4E-CB4CCA059FC4}" type="datetimeFigureOut">
               <a:rPr lang="en-US" smtClean="0"/>
-              <a:t>8/15/2026</a:t>
+              <a:t>8/16/2026</a:t>
             </a:fld>
             <a:endParaRPr lang="en-US"/>
           </a:p>
@@ -1346,7 +1346,7 @@
           <a:p>
             <a:fld id="{5BCAD085-E8A6-8845-BD4E-CB4CCA059FC4}" type="datetimeFigureOut">
               <a:rPr lang="en-US" smtClean="0"/>
-              <a:t>8/15/2026</a:t>
+              <a:t>8/16/2026</a:t>
             </a:fld>
             <a:endParaRPr lang="en-US"/>
           </a:p>
@@ -1765,7 +1765,7 @@
           <a:p>
             <a:fld id="{5BCAD085-E8A6-8845-BD4E-CB4CCA059FC4}" type="datetimeFigureOut">
               <a:rPr lang="en-US" smtClean="0"/>
-              <a:t>8/15/2026</a:t>
+              <a:t>8/16/2026</a:t>
             </a:fld>
             <a:endParaRPr lang="en-US"/>
           </a:p>
@@ -1882,7 +1882,7 @@
           <a:p>
             <a:fld id="{5BCAD085-E8A6-8845-BD4E-CB4CCA059FC4}" type="datetimeFigureOut">
               <a:rPr lang="en-US" smtClean="0"/>
-              <a:t>8/15/2026</a:t>
+              <a:t>8/16/2026</a:t>
             </a:fld>
             <a:endParaRPr lang="en-US"/>
           </a:p>
@@ -1977,7 +1977,7 @@
           <a:p>
             <a:fld id="{5BCAD085-E8A6-8845-BD4E-CB4CCA059FC4}" type="datetimeFigureOut">
               <a:rPr lang="en-US" smtClean="0"/>
-              <a:t>8/15/2026</a:t>
+              <a:t>8/16/2026</a:t>
             </a:fld>
             <a:endParaRPr lang="en-US"/>
           </a:p>
@@ -2252,7 +2252,7 @@
           <a:p>
             <a:fld id="{5BCAD085-E8A6-8845-BD4E-CB4CCA059FC4}" type="datetimeFigureOut">
               <a:rPr lang="en-US" smtClean="0"/>
-              <a:t>8/15/2026</a:t>
+              <a:t>8/16/2026</a:t>
             </a:fld>
             <a:endParaRPr lang="en-US"/>
           </a:p>
@@ -2504,7 +2504,7 @@
           <a:p>
             <a:fld id="{5BCAD085-E8A6-8845-BD4E-CB4CCA059FC4}" type="datetimeFigureOut">
               <a:rPr lang="en-US" smtClean="0"/>
-              <a:t>8/15/2026</a:t>
+              <a:t>8/16/2026</a:t>
             </a:fld>
             <a:endParaRPr lang="en-US"/>
           </a:p>
@@ -2715,7 +2715,7 @@
           <a:p>
             <a:fld id="{5BCAD085-E8A6-8845-BD4E-CB4CCA059FC4}" type="datetimeFigureOut">
               <a:rPr lang="en-US" smtClean="0"/>
-              <a:t>8/15/2026</a:t>
+              <a:t>8/16/2026</a:t>
             </a:fld>
             <a:endParaRPr lang="en-US"/>
           </a:p>
@@ -5096,7 +5096,7 @@
         <p:spPr>
           <a:xfrm>
             <a:off x="822960" y="4072022"/>
-            <a:ext cx="3840480" cy="329184"/>
+            <a:ext cx="3840480" cy="349070"/>
           </a:xfrm>
           <a:prstGeom prst="rect">
             <a:avLst/>
@@ -5109,7 +5109,7 @@
           </a:bodyPr>
           <a:lstStyle/>
           <a:p>
-            <a:pPr algn="l">
+            <a:pPr algn="just">
               <a:lnSpc>
                 <a:spcPct val="122000"/>
               </a:lnSpc>
@@ -5606,7 +5606,7 @@
         <p:spPr>
           <a:xfrm>
             <a:off x="4846320" y="4127290"/>
-            <a:ext cx="3017520" cy="292608"/>
+            <a:ext cx="3017520" cy="349070"/>
           </a:xfrm>
           <a:prstGeom prst="rect">
             <a:avLst/>
@@ -5619,7 +5619,7 @@
           </a:bodyPr>
           <a:lstStyle/>
           <a:p>
-            <a:pPr algn="l">
+            <a:pPr algn="just">
               <a:lnSpc>
                 <a:spcPct val="122000"/>
               </a:lnSpc>
@@ -6071,7 +6071,7 @@
         <p:spPr>
           <a:xfrm>
             <a:off x="8138160" y="4000501"/>
-            <a:ext cx="3227832" cy="393192"/>
+            <a:ext cx="3227832" cy="469231"/>
           </a:xfrm>
           <a:prstGeom prst="rect">
             <a:avLst/>
@@ -6084,7 +6084,7 @@
           </a:bodyPr>
           <a:lstStyle/>
           <a:p>
-            <a:pPr algn="l">
+            <a:pPr algn="just">
               <a:lnSpc>
                 <a:spcPct val="122000"/>
               </a:lnSpc>
@@ -10044,7 +10044,7 @@
         </p:nvSpPr>
         <p:spPr>
           <a:xfrm>
-            <a:off x="9363456" y="4626864"/>
+            <a:off x="7232904" y="4626864"/>
             <a:ext cx="1965960" cy="164592"/>
           </a:xfrm>
           <a:prstGeom prst="rect">
@@ -10089,8 +10089,8 @@
         </p:nvSpPr>
         <p:spPr>
           <a:xfrm>
-            <a:off x="9363456" y="4901183"/>
-            <a:ext cx="1965960" cy="1499616"/>
+            <a:off x="7232904" y="4901183"/>
+            <a:ext cx="1965960" cy="1233543"/>
           </a:xfrm>
           <a:prstGeom prst="rect">
             <a:avLst/>
@@ -10103,7 +10103,7 @@
           </a:bodyPr>
           <a:lstStyle/>
           <a:p>
-            <a:pPr algn="l">
+            <a:pPr algn="just">
               <a:lnSpc>
                 <a:spcPct val="118000"/>
               </a:lnSpc>
@@ -10115,7 +10115,7 @@
               </a:spcAft>
             </a:pPr>
             <a:r>
-              <a:rPr sz="600" b="1">
+              <a:rPr sz="600" b="1" dirty="0">
                 <a:solidFill>
                   <a:srgbClr val="E8EDF2"/>
                 </a:solidFill>
@@ -10124,17 +10124,143 @@
               <a:t>Termos fora da diagonal no Ω. </a:t>
             </a:r>
             <a:r>
-              <a:rPr sz="600" b="0">
-                <a:solidFill>
-                  <a:srgbClr val="6B8299"/>
-                </a:solidFill>
-                <a:latin typeface="Segoe UI"/>
-              </a:rPr>
-              <a:t>É a limitação com endereço mais claro: a correlação entre views já está medida.</a:t>
-            </a:r>
-          </a:p>
-          <a:p>
-            <a:pPr algn="l">
+              <a:rPr sz="600" b="0" dirty="0">
+                <a:solidFill>
+                  <a:srgbClr val="6B8299"/>
+                </a:solidFill>
+                <a:latin typeface="Segoe UI"/>
+              </a:rPr>
+              <a:t>É a </a:t>
+            </a:r>
+            <a:r>
+              <a:rPr sz="600" b="0" dirty="0" err="1">
+                <a:solidFill>
+                  <a:srgbClr val="6B8299"/>
+                </a:solidFill>
+                <a:latin typeface="Segoe UI"/>
+              </a:rPr>
+              <a:t>limitação</a:t>
+            </a:r>
+            <a:r>
+              <a:rPr sz="600" b="0" dirty="0">
+                <a:solidFill>
+                  <a:srgbClr val="6B8299"/>
+                </a:solidFill>
+                <a:latin typeface="Segoe UI"/>
+              </a:rPr>
+              <a:t> com </a:t>
+            </a:r>
+            <a:r>
+              <a:rPr sz="600" b="0" dirty="0" err="1">
+                <a:solidFill>
+                  <a:srgbClr val="6B8299"/>
+                </a:solidFill>
+                <a:latin typeface="Segoe UI"/>
+              </a:rPr>
+              <a:t>endereço</a:t>
+            </a:r>
+            <a:r>
+              <a:rPr sz="600" b="0" dirty="0">
+                <a:solidFill>
+                  <a:srgbClr val="6B8299"/>
+                </a:solidFill>
+                <a:latin typeface="Segoe UI"/>
+              </a:rPr>
+              <a:t> </a:t>
+            </a:r>
+            <a:r>
+              <a:rPr sz="600" b="0" dirty="0" err="1">
+                <a:solidFill>
+                  <a:srgbClr val="6B8299"/>
+                </a:solidFill>
+                <a:latin typeface="Segoe UI"/>
+              </a:rPr>
+              <a:t>mais</a:t>
+            </a:r>
+            <a:r>
+              <a:rPr sz="600" b="0" dirty="0">
+                <a:solidFill>
+                  <a:srgbClr val="6B8299"/>
+                </a:solidFill>
+                <a:latin typeface="Segoe UI"/>
+              </a:rPr>
+              <a:t> claro: a </a:t>
+            </a:r>
+            <a:r>
+              <a:rPr sz="600" b="0" dirty="0" err="1">
+                <a:solidFill>
+                  <a:srgbClr val="6B8299"/>
+                </a:solidFill>
+                <a:latin typeface="Segoe UI"/>
+              </a:rPr>
+              <a:t>correlação</a:t>
+            </a:r>
+            <a:r>
+              <a:rPr sz="600" b="0" dirty="0">
+                <a:solidFill>
+                  <a:srgbClr val="6B8299"/>
+                </a:solidFill>
+                <a:latin typeface="Segoe UI"/>
+              </a:rPr>
+              <a:t> entre views </a:t>
+            </a:r>
+            <a:r>
+              <a:rPr sz="600" b="0" dirty="0" err="1">
+                <a:solidFill>
+                  <a:srgbClr val="6B8299"/>
+                </a:solidFill>
+                <a:latin typeface="Segoe UI"/>
+              </a:rPr>
+              <a:t>já</a:t>
+            </a:r>
+            <a:r>
+              <a:rPr sz="600" b="0" dirty="0">
+                <a:solidFill>
+                  <a:srgbClr val="6B8299"/>
+                </a:solidFill>
+                <a:latin typeface="Segoe UI"/>
+              </a:rPr>
+              <a:t> </a:t>
+            </a:r>
+            <a:r>
+              <a:rPr sz="600" b="0" dirty="0" err="1">
+                <a:solidFill>
+                  <a:srgbClr val="6B8299"/>
+                </a:solidFill>
+                <a:latin typeface="Segoe UI"/>
+              </a:rPr>
+              <a:t>está</a:t>
+            </a:r>
+            <a:r>
+              <a:rPr sz="600" b="0" dirty="0">
+                <a:solidFill>
+                  <a:srgbClr val="6B8299"/>
+                </a:solidFill>
+                <a:latin typeface="Segoe UI"/>
+              </a:rPr>
+              <a:t> </a:t>
+            </a:r>
+            <a:r>
+              <a:rPr sz="600" b="0" dirty="0" err="1">
+                <a:solidFill>
+                  <a:srgbClr val="6B8299"/>
+                </a:solidFill>
+                <a:latin typeface="Segoe UI"/>
+              </a:rPr>
+              <a:t>medida</a:t>
+            </a:r>
+            <a:r>
+              <a:rPr sz="600" b="0" dirty="0">
+                <a:solidFill>
+                  <a:srgbClr val="6B8299"/>
+                </a:solidFill>
+                <a:latin typeface="Segoe UI"/>
+              </a:rPr>
+              <a:t>.</a:t>
+            </a:r>
+          </a:p>
+          <a:p>
+            <a:pPr algn="just">
               <a:lnSpc>
                 <a:spcPct val="118000"/>
               </a:lnSpc>
@@ -10146,26 +10272,296 @@
               </a:spcAft>
             </a:pPr>
             <a:r>
-              <a:rPr sz="600" b="1">
-                <a:solidFill>
-                  <a:srgbClr val="E8EDF2"/>
-                </a:solidFill>
-                <a:latin typeface="Segoe UI"/>
-              </a:rPr>
-              <a:t>Banda de não-negociação. </a:t>
-            </a:r>
-            <a:r>
-              <a:rPr sz="600" b="0">
-                <a:solidFill>
-                  <a:srgbClr val="6B8299"/>
-                </a:solidFill>
-                <a:latin typeface="Segoe UI"/>
-              </a:rPr>
-              <a:t>Contra os 42% de giro desfeito em dois pregões — o breakeven de 22,9 bps por lado diz que há espaço para não negociar.</a:t>
-            </a:r>
-          </a:p>
-          <a:p>
-            <a:pPr algn="l">
+              <a:rPr sz="600" b="1" dirty="0">
+                <a:solidFill>
+                  <a:srgbClr val="E8EDF2"/>
+                </a:solidFill>
+                <a:latin typeface="Segoe UI"/>
+              </a:rPr>
+              <a:t>Banda de </a:t>
+            </a:r>
+            <a:r>
+              <a:rPr sz="600" b="1" dirty="0" err="1">
+                <a:solidFill>
+                  <a:srgbClr val="E8EDF2"/>
+                </a:solidFill>
+                <a:latin typeface="Segoe UI"/>
+              </a:rPr>
+              <a:t>não-negociação</a:t>
+            </a:r>
+            <a:r>
+              <a:rPr sz="600" b="1" dirty="0">
+                <a:solidFill>
+                  <a:srgbClr val="E8EDF2"/>
+                </a:solidFill>
+                <a:latin typeface="Segoe UI"/>
+              </a:rPr>
+              <a:t>. </a:t>
+            </a:r>
+            <a:r>
+              <a:rPr sz="600" b="0" dirty="0">
+                <a:solidFill>
+                  <a:srgbClr val="6B8299"/>
+                </a:solidFill>
+                <a:latin typeface="Segoe UI"/>
+              </a:rPr>
+              <a:t>Contra </a:t>
+            </a:r>
+            <a:r>
+              <a:rPr sz="600" b="0" dirty="0" err="1">
+                <a:solidFill>
+                  <a:srgbClr val="6B8299"/>
+                </a:solidFill>
+                <a:latin typeface="Segoe UI"/>
+              </a:rPr>
+              <a:t>os</a:t>
+            </a:r>
+            <a:r>
+              <a:rPr sz="600" b="0" dirty="0">
+                <a:solidFill>
+                  <a:srgbClr val="6B8299"/>
+                </a:solidFill>
+                <a:latin typeface="Segoe UI"/>
+              </a:rPr>
+              <a:t> 42% de </a:t>
+            </a:r>
+            <a:r>
+              <a:rPr sz="600" b="0" dirty="0" err="1">
+                <a:solidFill>
+                  <a:srgbClr val="6B8299"/>
+                </a:solidFill>
+                <a:latin typeface="Segoe UI"/>
+              </a:rPr>
+              <a:t>giro</a:t>
+            </a:r>
+            <a:r>
+              <a:rPr sz="600" b="0" dirty="0">
+                <a:solidFill>
+                  <a:srgbClr val="6B8299"/>
+                </a:solidFill>
+                <a:latin typeface="Segoe UI"/>
+              </a:rPr>
+              <a:t> </a:t>
+            </a:r>
+            <a:r>
+              <a:rPr sz="600" b="0" dirty="0" err="1">
+                <a:solidFill>
+                  <a:srgbClr val="6B8299"/>
+                </a:solidFill>
+                <a:latin typeface="Segoe UI"/>
+              </a:rPr>
+              <a:t>desfeito</a:t>
+            </a:r>
+            <a:r>
+              <a:rPr sz="600" b="0" dirty="0">
+                <a:solidFill>
+                  <a:srgbClr val="6B8299"/>
+                </a:solidFill>
+                <a:latin typeface="Segoe UI"/>
+              </a:rPr>
+              <a:t> </a:t>
+            </a:r>
+            <a:r>
+              <a:rPr sz="600" b="0" dirty="0" err="1">
+                <a:solidFill>
+                  <a:srgbClr val="6B8299"/>
+                </a:solidFill>
+                <a:latin typeface="Segoe UI"/>
+              </a:rPr>
+              <a:t>em</a:t>
+            </a:r>
+            <a:r>
+              <a:rPr sz="600" b="0" dirty="0">
+                <a:solidFill>
+                  <a:srgbClr val="6B8299"/>
+                </a:solidFill>
+                <a:latin typeface="Segoe UI"/>
+              </a:rPr>
+              <a:t> </a:t>
+            </a:r>
+            <a:r>
+              <a:rPr sz="600" b="0" dirty="0" err="1">
+                <a:solidFill>
+                  <a:srgbClr val="6B8299"/>
+                </a:solidFill>
+                <a:latin typeface="Segoe UI"/>
+              </a:rPr>
+              <a:t>dois</a:t>
+            </a:r>
+            <a:r>
+              <a:rPr sz="600" b="0" dirty="0">
+                <a:solidFill>
+                  <a:srgbClr val="6B8299"/>
+                </a:solidFill>
+                <a:latin typeface="Segoe UI"/>
+              </a:rPr>
+              <a:t> </a:t>
+            </a:r>
+            <a:r>
+              <a:rPr sz="600" b="0" dirty="0" err="1">
+                <a:solidFill>
+                  <a:srgbClr val="6B8299"/>
+                </a:solidFill>
+                <a:latin typeface="Segoe UI"/>
+              </a:rPr>
+              <a:t>pregões</a:t>
+            </a:r>
+            <a:r>
+              <a:rPr sz="600" b="0" dirty="0">
+                <a:solidFill>
+                  <a:srgbClr val="6B8299"/>
+                </a:solidFill>
+                <a:latin typeface="Segoe UI"/>
+              </a:rPr>
+              <a:t> — o breakeven de 22,9 bps </a:t>
+            </a:r>
+            <a:r>
+              <a:rPr sz="600" b="0" dirty="0" err="1">
+                <a:solidFill>
+                  <a:srgbClr val="6B8299"/>
+                </a:solidFill>
+                <a:latin typeface="Segoe UI"/>
+              </a:rPr>
+              <a:t>por</a:t>
+            </a:r>
+            <a:r>
+              <a:rPr sz="600" b="0" dirty="0">
+                <a:solidFill>
+                  <a:srgbClr val="6B8299"/>
+                </a:solidFill>
+                <a:latin typeface="Segoe UI"/>
+              </a:rPr>
+              <a:t> </a:t>
+            </a:r>
+            <a:r>
+              <a:rPr sz="600" b="0" dirty="0" err="1">
+                <a:solidFill>
+                  <a:srgbClr val="6B8299"/>
+                </a:solidFill>
+                <a:latin typeface="Segoe UI"/>
+              </a:rPr>
+              <a:t>lado</a:t>
+            </a:r>
+            <a:r>
+              <a:rPr sz="600" b="0" dirty="0">
+                <a:solidFill>
+                  <a:srgbClr val="6B8299"/>
+                </a:solidFill>
+                <a:latin typeface="Segoe UI"/>
+              </a:rPr>
+              <a:t> </a:t>
+            </a:r>
+            <a:r>
+              <a:rPr sz="600" b="0" dirty="0" err="1">
+                <a:solidFill>
+                  <a:srgbClr val="6B8299"/>
+                </a:solidFill>
+                <a:latin typeface="Segoe UI"/>
+              </a:rPr>
+              <a:t>diz</a:t>
+            </a:r>
+            <a:r>
+              <a:rPr sz="600" b="0" dirty="0">
+                <a:solidFill>
+                  <a:srgbClr val="6B8299"/>
+                </a:solidFill>
+                <a:latin typeface="Segoe UI"/>
+              </a:rPr>
+              <a:t> </a:t>
+            </a:r>
+            <a:r>
+              <a:rPr sz="600" b="0" dirty="0" err="1">
+                <a:solidFill>
+                  <a:srgbClr val="6B8299"/>
+                </a:solidFill>
+                <a:latin typeface="Segoe UI"/>
+              </a:rPr>
+              <a:t>que</a:t>
+            </a:r>
+            <a:r>
+              <a:rPr sz="600" b="0" dirty="0">
+                <a:solidFill>
+                  <a:srgbClr val="6B8299"/>
+                </a:solidFill>
+                <a:latin typeface="Segoe UI"/>
+              </a:rPr>
+              <a:t> </a:t>
+            </a:r>
+            <a:r>
+              <a:rPr sz="600" b="0" dirty="0" err="1">
+                <a:solidFill>
+                  <a:srgbClr val="6B8299"/>
+                </a:solidFill>
+                <a:latin typeface="Segoe UI"/>
+              </a:rPr>
+              <a:t>há</a:t>
+            </a:r>
+            <a:r>
+              <a:rPr sz="600" b="0" dirty="0">
+                <a:solidFill>
+                  <a:srgbClr val="6B8299"/>
+                </a:solidFill>
+                <a:latin typeface="Segoe UI"/>
+              </a:rPr>
+              <a:t> </a:t>
+            </a:r>
+            <a:r>
+              <a:rPr sz="600" b="0" dirty="0" err="1">
+                <a:solidFill>
+                  <a:srgbClr val="6B8299"/>
+                </a:solidFill>
+                <a:latin typeface="Segoe UI"/>
+              </a:rPr>
+              <a:t>espaço</a:t>
+            </a:r>
+            <a:r>
+              <a:rPr sz="600" b="0" dirty="0">
+                <a:solidFill>
+                  <a:srgbClr val="6B8299"/>
+                </a:solidFill>
+                <a:latin typeface="Segoe UI"/>
+              </a:rPr>
+              <a:t> para </a:t>
+            </a:r>
+            <a:r>
+              <a:rPr sz="600" b="0" dirty="0" err="1">
+                <a:solidFill>
+                  <a:srgbClr val="6B8299"/>
+                </a:solidFill>
+                <a:latin typeface="Segoe UI"/>
+              </a:rPr>
+              <a:t>não</a:t>
+            </a:r>
+            <a:r>
+              <a:rPr sz="600" b="0" dirty="0">
+                <a:solidFill>
+                  <a:srgbClr val="6B8299"/>
+                </a:solidFill>
+                <a:latin typeface="Segoe UI"/>
+              </a:rPr>
+              <a:t> </a:t>
+            </a:r>
+            <a:r>
+              <a:rPr sz="600" b="0" dirty="0" err="1">
+                <a:solidFill>
+                  <a:srgbClr val="6B8299"/>
+                </a:solidFill>
+                <a:latin typeface="Segoe UI"/>
+              </a:rPr>
+              <a:t>negociar</a:t>
+            </a:r>
+            <a:r>
+              <a:rPr sz="600" b="0" dirty="0">
+                <a:solidFill>
+                  <a:srgbClr val="6B8299"/>
+                </a:solidFill>
+                <a:latin typeface="Segoe UI"/>
+              </a:rPr>
+              <a:t>.</a:t>
+            </a:r>
+          </a:p>
+          <a:p>
+            <a:pPr algn="just">
               <a:lnSpc>
                 <a:spcPct val="118000"/>
               </a:lnSpc>
@@ -10177,26 +10573,260 @@
               </a:spcAft>
             </a:pPr>
             <a:r>
-              <a:rPr sz="600" b="1">
-                <a:solidFill>
-                  <a:srgbClr val="E8EDF2"/>
-                </a:solidFill>
-                <a:latin typeface="Segoe UI"/>
-              </a:rPr>
-              <a:t>Ampliar o universo pelo critério certo. </a:t>
-            </a:r>
-            <a:r>
-              <a:rPr sz="600" b="0">
-                <a:solidFill>
-                  <a:srgbClr val="6B8299"/>
-                </a:solidFill>
-                <a:latin typeface="Segoe UI"/>
-              </a:rPr>
-              <a:t>Não por classe de ativo, e sim por haver notícia a que o preço responda.</a:t>
-            </a:r>
-          </a:p>
-          <a:p>
-            <a:pPr algn="l">
+              <a:rPr sz="600" b="1" dirty="0" err="1">
+                <a:solidFill>
+                  <a:srgbClr val="E8EDF2"/>
+                </a:solidFill>
+                <a:latin typeface="Segoe UI"/>
+              </a:rPr>
+              <a:t>Ampliar</a:t>
+            </a:r>
+            <a:r>
+              <a:rPr sz="600" b="1" dirty="0">
+                <a:solidFill>
+                  <a:srgbClr val="E8EDF2"/>
+                </a:solidFill>
+                <a:latin typeface="Segoe UI"/>
+              </a:rPr>
+              <a:t> o </a:t>
+            </a:r>
+            <a:r>
+              <a:rPr sz="600" b="1" dirty="0" err="1">
+                <a:solidFill>
+                  <a:srgbClr val="E8EDF2"/>
+                </a:solidFill>
+                <a:latin typeface="Segoe UI"/>
+              </a:rPr>
+              <a:t>universo</a:t>
+            </a:r>
+            <a:r>
+              <a:rPr sz="600" b="1" dirty="0">
+                <a:solidFill>
+                  <a:srgbClr val="E8EDF2"/>
+                </a:solidFill>
+                <a:latin typeface="Segoe UI"/>
+              </a:rPr>
+              <a:t> </a:t>
+            </a:r>
+            <a:r>
+              <a:rPr sz="600" b="1" dirty="0" err="1">
+                <a:solidFill>
+                  <a:srgbClr val="E8EDF2"/>
+                </a:solidFill>
+                <a:latin typeface="Segoe UI"/>
+              </a:rPr>
+              <a:t>pelo</a:t>
+            </a:r>
+            <a:r>
+              <a:rPr sz="600" b="1" dirty="0">
+                <a:solidFill>
+                  <a:srgbClr val="E8EDF2"/>
+                </a:solidFill>
+                <a:latin typeface="Segoe UI"/>
+              </a:rPr>
+              <a:t> </a:t>
+            </a:r>
+            <a:r>
+              <a:rPr sz="600" b="1" dirty="0" err="1">
+                <a:solidFill>
+                  <a:srgbClr val="E8EDF2"/>
+                </a:solidFill>
+                <a:latin typeface="Segoe UI"/>
+              </a:rPr>
+              <a:t>critério</a:t>
+            </a:r>
+            <a:r>
+              <a:rPr sz="600" b="1" dirty="0">
+                <a:solidFill>
+                  <a:srgbClr val="E8EDF2"/>
+                </a:solidFill>
+                <a:latin typeface="Segoe UI"/>
+              </a:rPr>
+              <a:t> </a:t>
+            </a:r>
+            <a:r>
+              <a:rPr sz="600" b="1" dirty="0" err="1">
+                <a:solidFill>
+                  <a:srgbClr val="E8EDF2"/>
+                </a:solidFill>
+                <a:latin typeface="Segoe UI"/>
+              </a:rPr>
+              <a:t>certo</a:t>
+            </a:r>
+            <a:r>
+              <a:rPr sz="600" b="1" dirty="0">
+                <a:solidFill>
+                  <a:srgbClr val="E8EDF2"/>
+                </a:solidFill>
+                <a:latin typeface="Segoe UI"/>
+              </a:rPr>
+              <a:t>. </a:t>
+            </a:r>
+            <a:r>
+              <a:rPr sz="600" b="0" dirty="0" err="1">
+                <a:solidFill>
+                  <a:srgbClr val="6B8299"/>
+                </a:solidFill>
+                <a:latin typeface="Segoe UI"/>
+              </a:rPr>
+              <a:t>Não</a:t>
+            </a:r>
+            <a:r>
+              <a:rPr sz="600" b="0" dirty="0">
+                <a:solidFill>
+                  <a:srgbClr val="6B8299"/>
+                </a:solidFill>
+                <a:latin typeface="Segoe UI"/>
+              </a:rPr>
+              <a:t> </a:t>
+            </a:r>
+            <a:r>
+              <a:rPr sz="600" b="0" dirty="0" err="1">
+                <a:solidFill>
+                  <a:srgbClr val="6B8299"/>
+                </a:solidFill>
+                <a:latin typeface="Segoe UI"/>
+              </a:rPr>
+              <a:t>por</a:t>
+            </a:r>
+            <a:r>
+              <a:rPr sz="600" b="0" dirty="0">
+                <a:solidFill>
+                  <a:srgbClr val="6B8299"/>
+                </a:solidFill>
+                <a:latin typeface="Segoe UI"/>
+              </a:rPr>
+              <a:t> </a:t>
+            </a:r>
+            <a:r>
+              <a:rPr sz="600" b="0" dirty="0" err="1">
+                <a:solidFill>
+                  <a:srgbClr val="6B8299"/>
+                </a:solidFill>
+                <a:latin typeface="Segoe UI"/>
+              </a:rPr>
+              <a:t>classe</a:t>
+            </a:r>
+            <a:r>
+              <a:rPr sz="600" b="0" dirty="0">
+                <a:solidFill>
+                  <a:srgbClr val="6B8299"/>
+                </a:solidFill>
+                <a:latin typeface="Segoe UI"/>
+              </a:rPr>
+              <a:t> de </a:t>
+            </a:r>
+            <a:r>
+              <a:rPr sz="600" b="0" dirty="0" err="1">
+                <a:solidFill>
+                  <a:srgbClr val="6B8299"/>
+                </a:solidFill>
+                <a:latin typeface="Segoe UI"/>
+              </a:rPr>
+              <a:t>ativo</a:t>
+            </a:r>
+            <a:r>
+              <a:rPr sz="600" b="0" dirty="0">
+                <a:solidFill>
+                  <a:srgbClr val="6B8299"/>
+                </a:solidFill>
+                <a:latin typeface="Segoe UI"/>
+              </a:rPr>
+              <a:t>, e sim </a:t>
+            </a:r>
+            <a:r>
+              <a:rPr sz="600" b="0" dirty="0" err="1">
+                <a:solidFill>
+                  <a:srgbClr val="6B8299"/>
+                </a:solidFill>
+                <a:latin typeface="Segoe UI"/>
+              </a:rPr>
+              <a:t>por</a:t>
+            </a:r>
+            <a:r>
+              <a:rPr sz="600" b="0" dirty="0">
+                <a:solidFill>
+                  <a:srgbClr val="6B8299"/>
+                </a:solidFill>
+                <a:latin typeface="Segoe UI"/>
+              </a:rPr>
+              <a:t> haver </a:t>
+            </a:r>
+            <a:r>
+              <a:rPr sz="600" b="0" dirty="0" err="1">
+                <a:solidFill>
+                  <a:srgbClr val="6B8299"/>
+                </a:solidFill>
+                <a:latin typeface="Segoe UI"/>
+              </a:rPr>
+              <a:t>notícia</a:t>
+            </a:r>
+            <a:r>
+              <a:rPr sz="600" b="0" dirty="0">
+                <a:solidFill>
+                  <a:srgbClr val="6B8299"/>
+                </a:solidFill>
+                <a:latin typeface="Segoe UI"/>
+              </a:rPr>
+              <a:t> a </a:t>
+            </a:r>
+            <a:r>
+              <a:rPr sz="600" b="0" dirty="0" err="1">
+                <a:solidFill>
+                  <a:srgbClr val="6B8299"/>
+                </a:solidFill>
+                <a:latin typeface="Segoe UI"/>
+              </a:rPr>
+              <a:t>que</a:t>
+            </a:r>
+            <a:r>
+              <a:rPr sz="600" b="0" dirty="0">
+                <a:solidFill>
+                  <a:srgbClr val="6B8299"/>
+                </a:solidFill>
+                <a:latin typeface="Segoe UI"/>
+              </a:rPr>
+              <a:t> o </a:t>
+            </a:r>
+            <a:r>
+              <a:rPr sz="600" b="0" dirty="0" err="1">
+                <a:solidFill>
+                  <a:srgbClr val="6B8299"/>
+                </a:solidFill>
+                <a:latin typeface="Segoe UI"/>
+              </a:rPr>
+              <a:t>preço</a:t>
+            </a:r>
+            <a:r>
+              <a:rPr sz="600" b="0" dirty="0">
+                <a:solidFill>
+                  <a:srgbClr val="6B8299"/>
+                </a:solidFill>
+                <a:latin typeface="Segoe UI"/>
+              </a:rPr>
+              <a:t> </a:t>
+            </a:r>
+            <a:r>
+              <a:rPr sz="600" b="0" dirty="0" err="1">
+                <a:solidFill>
+                  <a:srgbClr val="6B8299"/>
+                </a:solidFill>
+                <a:latin typeface="Segoe UI"/>
+              </a:rPr>
+              <a:t>responda</a:t>
+            </a:r>
+            <a:r>
+              <a:rPr sz="600" b="0" dirty="0">
+                <a:solidFill>
+                  <a:srgbClr val="6B8299"/>
+                </a:solidFill>
+                <a:latin typeface="Segoe UI"/>
+              </a:rPr>
+              <a:t>.</a:t>
+            </a:r>
+          </a:p>
+          <a:p>
+            <a:pPr algn="just">
               <a:lnSpc>
                 <a:spcPct val="118000"/>
               </a:lnSpc>
@@ -10208,450 +10838,216 @@
               </a:spcAft>
             </a:pPr>
             <a:r>
-              <a:rPr sz="600" b="1">
-                <a:solidFill>
-                  <a:srgbClr val="E8EDF2"/>
-                </a:solidFill>
-                <a:latin typeface="Segoe UI"/>
-              </a:rPr>
-              <a:t>Validar em regime de queda. </a:t>
-            </a:r>
-            <a:r>
-              <a:rPr sz="600" b="0">
-                <a:solidFill>
-                  <a:srgbClr val="6B8299"/>
-                </a:solidFill>
-                <a:latin typeface="Segoe UI"/>
-              </a:rPr>
-              <a:t>O que a página 4 admite é o que falta testar: a vantagem veio da subida.</a:t>
-            </a:r>
-          </a:p>
-        </p:txBody>
-      </p:sp>
-      <p:sp>
-        <p:nvSpPr>
-          <p:cNvPr id="46" name="TextBox 45"/>
-          <p:cNvSpPr txBox="1"/>
-          <p:nvPr/>
-        </p:nvSpPr>
-        <p:spPr>
-          <a:xfrm>
-            <a:off x="822960" y="6455664"/>
-            <a:ext cx="10543032" cy="164592"/>
-          </a:xfrm>
-          <a:prstGeom prst="rect">
-            <a:avLst/>
-          </a:prstGeom>
-          <a:noFill/>
-        </p:spPr>
-        <p:txBody>
-          <a:bodyPr wrap="square" lIns="0" tIns="0" rIns="0" bIns="0" anchor="t">
-            <a:spAutoFit/>
-          </a:bodyPr>
-          <a:lstStyle/>
-          <a:p>
-            <a:pPr algn="l">
-              <a:lnSpc>
-                <a:spcPct val="125000"/>
-              </a:lnSpc>
-              <a:spcBef>
-                <a:spcPts val="0"/>
-              </a:spcBef>
-              <a:spcAft>
-                <a:spcPts val="0"/>
-              </a:spcAft>
-            </a:pPr>
-            <a:r>
-              <a:rPr sz="700" b="1" dirty="0" err="1">
-                <a:solidFill>
-                  <a:srgbClr val="F5A623"/>
-                </a:solidFill>
-                <a:latin typeface="Segoe UI"/>
-              </a:rPr>
-              <a:t>Fechamento</a:t>
-            </a:r>
-            <a:r>
-              <a:rPr sz="700" b="1" dirty="0">
-                <a:solidFill>
-                  <a:srgbClr val="F5A623"/>
+              <a:rPr sz="600" b="1" dirty="0">
+                <a:solidFill>
+                  <a:srgbClr val="E8EDF2"/>
+                </a:solidFill>
+                <a:latin typeface="Segoe UI"/>
+              </a:rPr>
+              <a:t>Validar </a:t>
+            </a:r>
+            <a:r>
+              <a:rPr sz="600" b="1" dirty="0" err="1">
+                <a:solidFill>
+                  <a:srgbClr val="E8EDF2"/>
+                </a:solidFill>
+                <a:latin typeface="Segoe UI"/>
+              </a:rPr>
+              <a:t>em</a:t>
+            </a:r>
+            <a:r>
+              <a:rPr sz="600" b="1" dirty="0">
+                <a:solidFill>
+                  <a:srgbClr val="E8EDF2"/>
+                </a:solidFill>
+                <a:latin typeface="Segoe UI"/>
+              </a:rPr>
+              <a:t> regime de </a:t>
+            </a:r>
+            <a:r>
+              <a:rPr sz="600" b="1" dirty="0" err="1">
+                <a:solidFill>
+                  <a:srgbClr val="E8EDF2"/>
+                </a:solidFill>
+                <a:latin typeface="Segoe UI"/>
+              </a:rPr>
+              <a:t>queda</a:t>
+            </a:r>
+            <a:r>
+              <a:rPr sz="600" b="1" dirty="0">
+                <a:solidFill>
+                  <a:srgbClr val="E8EDF2"/>
                 </a:solidFill>
                 <a:latin typeface="Segoe UI"/>
               </a:rPr>
               <a:t>. </a:t>
             </a:r>
             <a:r>
-              <a:rPr sz="700" b="0" dirty="0" err="1">
-                <a:solidFill>
-                  <a:srgbClr val="9BAEC0"/>
-                </a:solidFill>
-                <a:latin typeface="Segoe UI"/>
-              </a:rPr>
-              <a:t>Kairós</a:t>
-            </a:r>
-            <a:r>
-              <a:rPr sz="700" b="0" dirty="0">
-                <a:solidFill>
-                  <a:srgbClr val="9BAEC0"/>
-                </a:solidFill>
-                <a:latin typeface="Segoe UI"/>
-              </a:rPr>
-              <a:t> </a:t>
-            </a:r>
-            <a:r>
-              <a:rPr sz="700" b="0" dirty="0" err="1">
-                <a:solidFill>
-                  <a:srgbClr val="9BAEC0"/>
-                </a:solidFill>
-                <a:latin typeface="Segoe UI"/>
-              </a:rPr>
-              <a:t>troca</a:t>
-            </a:r>
-            <a:r>
-              <a:rPr sz="700" b="0" dirty="0">
-                <a:solidFill>
-                  <a:srgbClr val="9BAEC0"/>
-                </a:solidFill>
-                <a:latin typeface="Segoe UI"/>
-              </a:rPr>
-              <a:t> </a:t>
-            </a:r>
-            <a:r>
-              <a:rPr sz="700" b="0" dirty="0" err="1">
-                <a:solidFill>
-                  <a:srgbClr val="9BAEC0"/>
-                </a:solidFill>
-                <a:latin typeface="Segoe UI"/>
-              </a:rPr>
-              <a:t>opinião</a:t>
-            </a:r>
-            <a:r>
-              <a:rPr sz="700" b="0" dirty="0">
-                <a:solidFill>
-                  <a:srgbClr val="9BAEC0"/>
-                </a:solidFill>
-                <a:latin typeface="Segoe UI"/>
-              </a:rPr>
-              <a:t> </a:t>
-            </a:r>
-            <a:r>
-              <a:rPr sz="700" b="0" dirty="0" err="1">
-                <a:solidFill>
-                  <a:srgbClr val="9BAEC0"/>
-                </a:solidFill>
-                <a:latin typeface="Segoe UI"/>
-              </a:rPr>
-              <a:t>por</a:t>
-            </a:r>
-            <a:r>
-              <a:rPr sz="700" b="0" dirty="0">
-                <a:solidFill>
-                  <a:srgbClr val="9BAEC0"/>
-                </a:solidFill>
-                <a:latin typeface="Segoe UI"/>
-              </a:rPr>
-              <a:t> </a:t>
-            </a:r>
-            <a:r>
-              <a:rPr sz="700" b="0" dirty="0" err="1">
-                <a:solidFill>
-                  <a:srgbClr val="9BAEC0"/>
-                </a:solidFill>
-                <a:latin typeface="Segoe UI"/>
-              </a:rPr>
-              <a:t>preço</a:t>
-            </a:r>
-            <a:r>
-              <a:rPr sz="700" b="0" dirty="0">
-                <a:solidFill>
-                  <a:srgbClr val="9BAEC0"/>
-                </a:solidFill>
-                <a:latin typeface="Segoe UI"/>
-              </a:rPr>
-              <a:t> </a:t>
-            </a:r>
-            <a:r>
-              <a:rPr sz="700" b="0" dirty="0" err="1">
-                <a:solidFill>
-                  <a:srgbClr val="9BAEC0"/>
-                </a:solidFill>
-                <a:latin typeface="Segoe UI"/>
-              </a:rPr>
-              <a:t>observável</a:t>
-            </a:r>
-            <a:r>
-              <a:rPr sz="700" b="0" dirty="0">
-                <a:solidFill>
-                  <a:srgbClr val="9BAEC0"/>
-                </a:solidFill>
-                <a:latin typeface="Segoe UI"/>
-              </a:rPr>
-              <a:t>: o </a:t>
-            </a:r>
-            <a:r>
-              <a:rPr sz="700" b="0" dirty="0" err="1">
-                <a:solidFill>
-                  <a:srgbClr val="9BAEC0"/>
+              <a:rPr sz="600" b="0" dirty="0">
+                <a:solidFill>
+                  <a:srgbClr val="6B8299"/>
+                </a:solidFill>
+                <a:latin typeface="Segoe UI"/>
+              </a:rPr>
+              <a:t>O </a:t>
+            </a:r>
+            <a:r>
+              <a:rPr sz="600" b="0" dirty="0" err="1">
+                <a:solidFill>
+                  <a:srgbClr val="6B8299"/>
                 </a:solidFill>
                 <a:latin typeface="Segoe UI"/>
               </a:rPr>
               <a:t>que</a:t>
             </a:r>
             <a:r>
-              <a:rPr sz="700" b="0" dirty="0">
-                <a:solidFill>
-                  <a:srgbClr val="9BAEC0"/>
+              <a:rPr sz="600" b="0" dirty="0">
+                <a:solidFill>
+                  <a:srgbClr val="6B8299"/>
                 </a:solidFill>
                 <a:latin typeface="Segoe UI"/>
               </a:rPr>
               <a:t> a </a:t>
             </a:r>
             <a:r>
-              <a:rPr sz="700" b="0" dirty="0" err="1">
-                <a:solidFill>
-                  <a:srgbClr val="9BAEC0"/>
-                </a:solidFill>
-                <a:latin typeface="Segoe UI"/>
-              </a:rPr>
-              <a:t>estratégia</a:t>
-            </a:r>
-            <a:r>
-              <a:rPr sz="700" b="0" dirty="0">
-                <a:solidFill>
-                  <a:srgbClr val="9BAEC0"/>
-                </a:solidFill>
-                <a:latin typeface="Segoe UI"/>
-              </a:rPr>
-              <a:t> </a:t>
-            </a:r>
-            <a:r>
-              <a:rPr sz="700" b="0" dirty="0" err="1">
-                <a:solidFill>
-                  <a:srgbClr val="9BAEC0"/>
-                </a:solidFill>
-                <a:latin typeface="Segoe UI"/>
-              </a:rPr>
-              <a:t>entrega</a:t>
-            </a:r>
-            <a:r>
-              <a:rPr sz="700" b="0" dirty="0">
-                <a:solidFill>
-                  <a:srgbClr val="9BAEC0"/>
-                </a:solidFill>
-                <a:latin typeface="Segoe UI"/>
-              </a:rPr>
-              <a:t> é </a:t>
-            </a:r>
-            <a:r>
-              <a:rPr sz="700" b="0" dirty="0" err="1">
-                <a:solidFill>
-                  <a:srgbClr val="9BAEC0"/>
-                </a:solidFill>
-                <a:latin typeface="Segoe UI"/>
-              </a:rPr>
-              <a:t>disciplina</a:t>
-            </a:r>
-            <a:r>
-              <a:rPr sz="700" b="0" dirty="0">
-                <a:solidFill>
-                  <a:srgbClr val="9BAEC0"/>
-                </a:solidFill>
-                <a:latin typeface="Segoe UI"/>
-              </a:rPr>
-              <a:t>, </a:t>
-            </a:r>
-            <a:r>
-              <a:rPr sz="700" b="0" dirty="0" err="1">
-                <a:solidFill>
-                  <a:srgbClr val="9BAEC0"/>
-                </a:solidFill>
-                <a:latin typeface="Segoe UI"/>
-              </a:rPr>
-              <a:t>não</a:t>
-            </a:r>
-            <a:r>
-              <a:rPr sz="700" b="0" dirty="0">
-                <a:solidFill>
-                  <a:srgbClr val="9BAEC0"/>
-                </a:solidFill>
-                <a:latin typeface="Segoe UI"/>
-              </a:rPr>
-              <a:t> </a:t>
-            </a:r>
-            <a:r>
-              <a:rPr sz="700" b="0" dirty="0" err="1">
-                <a:solidFill>
-                  <a:srgbClr val="9BAEC0"/>
-                </a:solidFill>
-                <a:latin typeface="Segoe UI"/>
-              </a:rPr>
-              <a:t>adivinhação</a:t>
-            </a:r>
-            <a:r>
-              <a:rPr sz="700" b="0" dirty="0">
-                <a:solidFill>
-                  <a:srgbClr val="9BAEC0"/>
-                </a:solidFill>
-                <a:latin typeface="Segoe UI"/>
-              </a:rPr>
-              <a:t> — e a </a:t>
-            </a:r>
-            <a:r>
-              <a:rPr sz="700" b="0" dirty="0" err="1">
-                <a:solidFill>
-                  <a:srgbClr val="9BAEC0"/>
-                </a:solidFill>
-                <a:latin typeface="Segoe UI"/>
-              </a:rPr>
-              <a:t>mesma</a:t>
-            </a:r>
-            <a:r>
-              <a:rPr sz="700" b="0" dirty="0">
-                <a:solidFill>
-                  <a:srgbClr val="9BAEC0"/>
-                </a:solidFill>
-                <a:latin typeface="Segoe UI"/>
-              </a:rPr>
-              <a:t> </a:t>
-            </a:r>
-            <a:r>
-              <a:rPr sz="700" b="0" dirty="0" err="1">
-                <a:solidFill>
-                  <a:srgbClr val="9BAEC0"/>
-                </a:solidFill>
-                <a:latin typeface="Segoe UI"/>
-              </a:rPr>
-              <a:t>regra</a:t>
-            </a:r>
-            <a:r>
-              <a:rPr sz="700" b="0" dirty="0">
-                <a:solidFill>
-                  <a:srgbClr val="9BAEC0"/>
-                </a:solidFill>
-                <a:latin typeface="Segoe UI"/>
-              </a:rPr>
-              <a:t> </a:t>
-            </a:r>
-            <a:r>
-              <a:rPr sz="700" b="0" dirty="0" err="1">
-                <a:solidFill>
-                  <a:srgbClr val="9BAEC0"/>
+              <a:rPr sz="600" b="0" dirty="0" err="1">
+                <a:solidFill>
+                  <a:srgbClr val="6B8299"/>
+                </a:solidFill>
+                <a:latin typeface="Segoe UI"/>
+              </a:rPr>
+              <a:t>página</a:t>
+            </a:r>
+            <a:r>
+              <a:rPr sz="600" b="0" dirty="0">
+                <a:solidFill>
+                  <a:srgbClr val="6B8299"/>
+                </a:solidFill>
+                <a:latin typeface="Segoe UI"/>
+              </a:rPr>
+              <a:t> 4 </a:t>
+            </a:r>
+            <a:r>
+              <a:rPr sz="600" b="0" dirty="0" err="1">
+                <a:solidFill>
+                  <a:srgbClr val="6B8299"/>
+                </a:solidFill>
+                <a:latin typeface="Segoe UI"/>
+              </a:rPr>
+              <a:t>admite</a:t>
+            </a:r>
+            <a:r>
+              <a:rPr sz="600" b="0" dirty="0">
+                <a:solidFill>
+                  <a:srgbClr val="6B8299"/>
+                </a:solidFill>
+                <a:latin typeface="Segoe UI"/>
+              </a:rPr>
+              <a:t> é o </a:t>
+            </a:r>
+            <a:r>
+              <a:rPr sz="600" b="0" dirty="0" err="1">
+                <a:solidFill>
+                  <a:srgbClr val="6B8299"/>
                 </a:solidFill>
                 <a:latin typeface="Segoe UI"/>
               </a:rPr>
               <a:t>que</a:t>
             </a:r>
             <a:r>
-              <a:rPr sz="700" b="0" dirty="0">
-                <a:solidFill>
-                  <a:srgbClr val="9BAEC0"/>
-                </a:solidFill>
-                <a:latin typeface="Segoe UI"/>
-              </a:rPr>
-              <a:t> a IA </a:t>
-            </a:r>
-            <a:r>
-              <a:rPr sz="700" b="0" dirty="0" err="1">
-                <a:solidFill>
-                  <a:srgbClr val="9BAEC0"/>
-                </a:solidFill>
-                <a:latin typeface="Segoe UI"/>
-              </a:rPr>
-              <a:t>seguiu</a:t>
-            </a:r>
-            <a:r>
-              <a:rPr sz="700" b="0" dirty="0">
-                <a:solidFill>
-                  <a:srgbClr val="9BAEC0"/>
-                </a:solidFill>
-                <a:latin typeface="Segoe UI"/>
-              </a:rPr>
-              <a:t> para </a:t>
-            </a:r>
-            <a:r>
-              <a:rPr sz="700" b="0" dirty="0" err="1">
-                <a:solidFill>
-                  <a:srgbClr val="9BAEC0"/>
-                </a:solidFill>
-                <a:latin typeface="Segoe UI"/>
-              </a:rPr>
-              <a:t>construí</a:t>
-            </a:r>
-            <a:r>
-              <a:rPr sz="700" b="0" dirty="0">
-                <a:solidFill>
-                  <a:srgbClr val="9BAEC0"/>
-                </a:solidFill>
-                <a:latin typeface="Segoe UI"/>
-              </a:rPr>
-              <a:t>-la é </a:t>
-            </a:r>
-            <a:r>
-              <a:rPr sz="700" b="0" dirty="0" err="1">
-                <a:solidFill>
-                  <a:srgbClr val="9BAEC0"/>
-                </a:solidFill>
-                <a:latin typeface="Segoe UI"/>
-              </a:rPr>
-              <a:t>essa</a:t>
-            </a:r>
-            <a:r>
-              <a:rPr sz="700" b="0" dirty="0">
-                <a:solidFill>
-                  <a:srgbClr val="9BAEC0"/>
-                </a:solidFill>
-                <a:latin typeface="Segoe UI"/>
-              </a:rPr>
-              <a:t>, </a:t>
-            </a:r>
-            <a:r>
-              <a:rPr sz="700" b="0" dirty="0" err="1">
-                <a:solidFill>
-                  <a:srgbClr val="9BAEC0"/>
-                </a:solidFill>
-                <a:latin typeface="Segoe UI"/>
-              </a:rPr>
-              <a:t>decisão</a:t>
-            </a:r>
-            <a:r>
-              <a:rPr sz="700" b="0" dirty="0">
-                <a:solidFill>
-                  <a:srgbClr val="9BAEC0"/>
-                </a:solidFill>
-                <a:latin typeface="Segoe UI"/>
-              </a:rPr>
-              <a:t> humana </a:t>
-            </a:r>
-            <a:r>
-              <a:rPr sz="700" b="0" dirty="0" err="1">
-                <a:solidFill>
-                  <a:srgbClr val="9BAEC0"/>
-                </a:solidFill>
-                <a:latin typeface="Segoe UI"/>
-              </a:rPr>
-              <a:t>registrada</a:t>
-            </a:r>
-            <a:r>
-              <a:rPr sz="700" b="0" dirty="0">
-                <a:solidFill>
-                  <a:srgbClr val="9BAEC0"/>
-                </a:solidFill>
-                <a:latin typeface="Segoe UI"/>
-              </a:rPr>
-              <a:t> antes do </a:t>
-            </a:r>
-            <a:r>
-              <a:rPr sz="700" b="0" dirty="0" err="1">
-                <a:solidFill>
-                  <a:srgbClr val="9BAEC0"/>
-                </a:solidFill>
-                <a:latin typeface="Segoe UI"/>
-              </a:rPr>
-              <a:t>número</a:t>
-            </a:r>
-            <a:r>
-              <a:rPr sz="700" b="0" dirty="0">
-                <a:solidFill>
-                  <a:srgbClr val="9BAEC0"/>
+              <a:rPr sz="600" b="0" dirty="0">
+                <a:solidFill>
+                  <a:srgbClr val="6B8299"/>
+                </a:solidFill>
+                <a:latin typeface="Segoe UI"/>
+              </a:rPr>
+              <a:t> </a:t>
+            </a:r>
+            <a:r>
+              <a:rPr sz="600" b="0" dirty="0" err="1">
+                <a:solidFill>
+                  <a:srgbClr val="6B8299"/>
+                </a:solidFill>
+                <a:latin typeface="Segoe UI"/>
+              </a:rPr>
+              <a:t>falta</a:t>
+            </a:r>
+            <a:r>
+              <a:rPr sz="600" b="0" dirty="0">
+                <a:solidFill>
+                  <a:srgbClr val="6B8299"/>
+                </a:solidFill>
+                <a:latin typeface="Segoe UI"/>
+              </a:rPr>
+              <a:t> </a:t>
+            </a:r>
+            <a:r>
+              <a:rPr sz="600" b="0" dirty="0" err="1">
+                <a:solidFill>
+                  <a:srgbClr val="6B8299"/>
+                </a:solidFill>
+                <a:latin typeface="Segoe UI"/>
+              </a:rPr>
+              <a:t>testar</a:t>
+            </a:r>
+            <a:r>
+              <a:rPr sz="600" b="0" dirty="0">
+                <a:solidFill>
+                  <a:srgbClr val="6B8299"/>
+                </a:solidFill>
+                <a:latin typeface="Segoe UI"/>
+              </a:rPr>
+              <a:t>: a </a:t>
+            </a:r>
+            <a:r>
+              <a:rPr sz="600" b="0" dirty="0" err="1">
+                <a:solidFill>
+                  <a:srgbClr val="6B8299"/>
+                </a:solidFill>
+                <a:latin typeface="Segoe UI"/>
+              </a:rPr>
+              <a:t>vantagem</a:t>
+            </a:r>
+            <a:r>
+              <a:rPr sz="600" b="0" dirty="0">
+                <a:solidFill>
+                  <a:srgbClr val="6B8299"/>
+                </a:solidFill>
+                <a:latin typeface="Segoe UI"/>
+              </a:rPr>
+              <a:t> </a:t>
+            </a:r>
+            <a:r>
+              <a:rPr sz="600" b="0" dirty="0" err="1">
+                <a:solidFill>
+                  <a:srgbClr val="6B8299"/>
+                </a:solidFill>
+                <a:latin typeface="Segoe UI"/>
+              </a:rPr>
+              <a:t>veio</a:t>
+            </a:r>
+            <a:r>
+              <a:rPr sz="600" b="0" dirty="0">
+                <a:solidFill>
+                  <a:srgbClr val="6B8299"/>
+                </a:solidFill>
+                <a:latin typeface="Segoe UI"/>
+              </a:rPr>
+              <a:t> da </a:t>
+            </a:r>
+            <a:r>
+              <a:rPr sz="600" b="0" dirty="0" err="1">
+                <a:solidFill>
+                  <a:srgbClr val="6B8299"/>
+                </a:solidFill>
+                <a:latin typeface="Segoe UI"/>
+              </a:rPr>
+              <a:t>subida</a:t>
+            </a:r>
+            <a:r>
+              <a:rPr sz="600" b="0" dirty="0">
+                <a:solidFill>
+                  <a:srgbClr val="6B8299"/>
                 </a:solidFill>
                 <a:latin typeface="Segoe UI"/>
               </a:rPr>
@@ -10668,7 +11064,7 @@
         </p:nvCxnSpPr>
         <p:spPr>
           <a:xfrm>
-            <a:off x="822960" y="6656832"/>
+            <a:off x="822960" y="6559440"/>
             <a:ext cx="10543032" cy="0"/>
           </a:xfrm>
           <a:prstGeom prst="line">
@@ -10703,8 +11099,8 @@
         </p:nvSpPr>
         <p:spPr>
           <a:xfrm>
-            <a:off x="822960" y="6702552"/>
-            <a:ext cx="10543032" cy="128016"/>
+            <a:off x="822960" y="6596118"/>
+            <a:ext cx="10543032" cy="104003"/>
           </a:xfrm>
           <a:prstGeom prst="rect">
             <a:avLst/>
@@ -10729,16 +11125,52 @@
               </a:spcAft>
             </a:pPr>
             <a:r>
-              <a:rPr sz="600" b="0">
-                <a:solidFill>
-                  <a:srgbClr val="6B8299"/>
-                </a:solidFill>
-                <a:latin typeface="Segoe UI"/>
-              </a:rPr>
-              <a:t>91 sessões e 19,7M de tokens lidos dos três </a:t>
-            </a:r>
-            <a:r>
-              <a:rPr sz="600" b="0">
+              <a:rPr sz="600" b="0" dirty="0">
+                <a:solidFill>
+                  <a:srgbClr val="6B8299"/>
+                </a:solidFill>
+                <a:latin typeface="Segoe UI"/>
+              </a:rPr>
+              <a:t>91 </a:t>
+            </a:r>
+            <a:r>
+              <a:rPr sz="600" b="0" dirty="0" err="1">
+                <a:solidFill>
+                  <a:srgbClr val="6B8299"/>
+                </a:solidFill>
+                <a:latin typeface="Segoe UI"/>
+              </a:rPr>
+              <a:t>sessões</a:t>
+            </a:r>
+            <a:r>
+              <a:rPr sz="600" b="0" dirty="0">
+                <a:solidFill>
+                  <a:srgbClr val="6B8299"/>
+                </a:solidFill>
+                <a:latin typeface="Segoe UI"/>
+              </a:rPr>
+              <a:t> e 19,7M de tokens lidos dos </a:t>
+            </a:r>
+            <a:r>
+              <a:rPr sz="600" b="0" dirty="0" err="1">
+                <a:solidFill>
+                  <a:srgbClr val="6B8299"/>
+                </a:solidFill>
+                <a:latin typeface="Segoe UI"/>
+              </a:rPr>
+              <a:t>três</a:t>
+            </a:r>
+            <a:r>
+              <a:rPr sz="600" b="0" dirty="0">
+                <a:solidFill>
+                  <a:srgbClr val="6B8299"/>
+                </a:solidFill>
+                <a:latin typeface="Segoe UI"/>
+              </a:rPr>
+              <a:t> </a:t>
+            </a:r>
+            <a:r>
+              <a:rPr sz="600" b="0" dirty="0">
                 <a:solidFill>
                   <a:srgbClr val="9BAEC0"/>
                 </a:solidFill>
@@ -10747,16 +11179,52 @@
               <a:t>LOG.md</a:t>
             </a:r>
             <a:r>
-              <a:rPr sz="600" b="0">
-                <a:solidFill>
-                  <a:srgbClr val="6B8299"/>
-                </a:solidFill>
-                <a:latin typeface="Segoe UI"/>
-              </a:rPr>
-              <a:t> do projeto (Felipe · Lia · Paulo) por </a:t>
-            </a:r>
-            <a:r>
-              <a:rPr sz="600" b="0">
+              <a:rPr sz="600" b="0" dirty="0">
+                <a:solidFill>
+                  <a:srgbClr val="6B8299"/>
+                </a:solidFill>
+                <a:latin typeface="Segoe UI"/>
+              </a:rPr>
+              <a:t> do </a:t>
+            </a:r>
+            <a:r>
+              <a:rPr sz="600" b="0" dirty="0" err="1">
+                <a:solidFill>
+                  <a:srgbClr val="6B8299"/>
+                </a:solidFill>
+                <a:latin typeface="Segoe UI"/>
+              </a:rPr>
+              <a:t>projeto</a:t>
+            </a:r>
+            <a:r>
+              <a:rPr sz="600" b="0" dirty="0">
+                <a:solidFill>
+                  <a:srgbClr val="6B8299"/>
+                </a:solidFill>
+                <a:latin typeface="Segoe UI"/>
+              </a:rPr>
+              <a:t> (Felipe · Lia · Paulo) </a:t>
+            </a:r>
+            <a:r>
+              <a:rPr sz="600" b="0" dirty="0" err="1">
+                <a:solidFill>
+                  <a:srgbClr val="6B8299"/>
+                </a:solidFill>
+                <a:latin typeface="Segoe UI"/>
+              </a:rPr>
+              <a:t>por</a:t>
+            </a:r>
+            <a:r>
+              <a:rPr sz="600" b="0" dirty="0">
+                <a:solidFill>
+                  <a:srgbClr val="6B8299"/>
+                </a:solidFill>
+                <a:latin typeface="Segoe UI"/>
+              </a:rPr>
+              <a:t> </a:t>
+            </a:r>
+            <a:r>
+              <a:rPr sz="600" b="0" dirty="0">
                 <a:solidFill>
                   <a:srgbClr val="9BAEC0"/>
                 </a:solidFill>
@@ -10765,25 +11233,268 @@
               <a:t>graficos_p5.py</a:t>
             </a:r>
             <a:r>
-              <a:rPr sz="600" b="0">
-                <a:solidFill>
-                  <a:srgbClr val="6B8299"/>
-                </a:solidFill>
-                <a:latin typeface="Segoe UI"/>
-              </a:rPr>
-              <a:t>. Tipo de sessão e taxonomia de erro são classificação manual, por regra declarada antes da contagem, linha a linha em </a:t>
-            </a:r>
-            <a:r>
-              <a:rPr sz="600" b="0">
+              <a:rPr sz="600" b="0" dirty="0">
+                <a:solidFill>
+                  <a:srgbClr val="6B8299"/>
+                </a:solidFill>
+                <a:latin typeface="Segoe UI"/>
+              </a:rPr>
+              <a:t>. Tipo de </a:t>
+            </a:r>
+            <a:r>
+              <a:rPr sz="600" b="0" dirty="0" err="1">
+                <a:solidFill>
+                  <a:srgbClr val="6B8299"/>
+                </a:solidFill>
+                <a:latin typeface="Segoe UI"/>
+              </a:rPr>
+              <a:t>sessão</a:t>
+            </a:r>
+            <a:r>
+              <a:rPr sz="600" b="0" dirty="0">
+                <a:solidFill>
+                  <a:srgbClr val="6B8299"/>
+                </a:solidFill>
+                <a:latin typeface="Segoe UI"/>
+              </a:rPr>
+              <a:t> e </a:t>
+            </a:r>
+            <a:r>
+              <a:rPr sz="600" b="0" dirty="0" err="1">
+                <a:solidFill>
+                  <a:srgbClr val="6B8299"/>
+                </a:solidFill>
+                <a:latin typeface="Segoe UI"/>
+              </a:rPr>
+              <a:t>taxonomia</a:t>
+            </a:r>
+            <a:r>
+              <a:rPr sz="600" b="0" dirty="0">
+                <a:solidFill>
+                  <a:srgbClr val="6B8299"/>
+                </a:solidFill>
+                <a:latin typeface="Segoe UI"/>
+              </a:rPr>
+              <a:t> de </a:t>
+            </a:r>
+            <a:r>
+              <a:rPr sz="600" b="0" dirty="0" err="1">
+                <a:solidFill>
+                  <a:srgbClr val="6B8299"/>
+                </a:solidFill>
+                <a:latin typeface="Segoe UI"/>
+              </a:rPr>
+              <a:t>erro</a:t>
+            </a:r>
+            <a:r>
+              <a:rPr sz="600" b="0" dirty="0">
+                <a:solidFill>
+                  <a:srgbClr val="6B8299"/>
+                </a:solidFill>
+                <a:latin typeface="Segoe UI"/>
+              </a:rPr>
+              <a:t> </a:t>
+            </a:r>
+            <a:r>
+              <a:rPr sz="600" b="0" dirty="0" err="1">
+                <a:solidFill>
+                  <a:srgbClr val="6B8299"/>
+                </a:solidFill>
+                <a:latin typeface="Segoe UI"/>
+              </a:rPr>
+              <a:t>são</a:t>
+            </a:r>
+            <a:r>
+              <a:rPr sz="600" b="0" dirty="0">
+                <a:solidFill>
+                  <a:srgbClr val="6B8299"/>
+                </a:solidFill>
+                <a:latin typeface="Segoe UI"/>
+              </a:rPr>
+              <a:t> </a:t>
+            </a:r>
+            <a:r>
+              <a:rPr sz="600" b="0" dirty="0" err="1">
+                <a:solidFill>
+                  <a:srgbClr val="6B8299"/>
+                </a:solidFill>
+                <a:latin typeface="Segoe UI"/>
+              </a:rPr>
+              <a:t>classificação</a:t>
+            </a:r>
+            <a:r>
+              <a:rPr sz="600" b="0" dirty="0">
+                <a:solidFill>
+                  <a:srgbClr val="6B8299"/>
+                </a:solidFill>
+                <a:latin typeface="Segoe UI"/>
+              </a:rPr>
+              <a:t> </a:t>
+            </a:r>
+            <a:r>
+              <a:rPr lang="pt-BR" sz="600" b="0" dirty="0">
+                <a:solidFill>
+                  <a:srgbClr val="6B8299"/>
+                </a:solidFill>
+                <a:latin typeface="Segoe UI"/>
+              </a:rPr>
+              <a:t>feita por IA</a:t>
+            </a:r>
+            <a:r>
+              <a:rPr sz="600" b="0" dirty="0">
+                <a:solidFill>
+                  <a:srgbClr val="6B8299"/>
+                </a:solidFill>
+                <a:latin typeface="Segoe UI"/>
+              </a:rPr>
+              <a:t>, </a:t>
+            </a:r>
+            <a:r>
+              <a:rPr sz="600" b="0" dirty="0" err="1">
+                <a:solidFill>
+                  <a:srgbClr val="6B8299"/>
+                </a:solidFill>
+                <a:latin typeface="Segoe UI"/>
+              </a:rPr>
+              <a:t>por</a:t>
+            </a:r>
+            <a:r>
+              <a:rPr sz="600" b="0" dirty="0">
+                <a:solidFill>
+                  <a:srgbClr val="6B8299"/>
+                </a:solidFill>
+                <a:latin typeface="Segoe UI"/>
+              </a:rPr>
+              <a:t> </a:t>
+            </a:r>
+            <a:r>
+              <a:rPr sz="600" b="0" dirty="0" err="1">
+                <a:solidFill>
+                  <a:srgbClr val="6B8299"/>
+                </a:solidFill>
+                <a:latin typeface="Segoe UI"/>
+              </a:rPr>
+              <a:t>regra</a:t>
+            </a:r>
+            <a:r>
+              <a:rPr sz="600" b="0" dirty="0">
+                <a:solidFill>
+                  <a:srgbClr val="6B8299"/>
+                </a:solidFill>
+                <a:latin typeface="Segoe UI"/>
+              </a:rPr>
+              <a:t> </a:t>
+            </a:r>
+            <a:r>
+              <a:rPr sz="600" b="0" dirty="0" err="1">
+                <a:solidFill>
+                  <a:srgbClr val="6B8299"/>
+                </a:solidFill>
+                <a:latin typeface="Segoe UI"/>
+              </a:rPr>
+              <a:t>declarada</a:t>
+            </a:r>
+            <a:r>
+              <a:rPr sz="600" b="0" dirty="0">
+                <a:solidFill>
+                  <a:srgbClr val="6B8299"/>
+                </a:solidFill>
+                <a:latin typeface="Segoe UI"/>
+              </a:rPr>
+              <a:t> antes da </a:t>
+            </a:r>
+            <a:r>
+              <a:rPr sz="600" b="0" dirty="0" err="1">
+                <a:solidFill>
+                  <a:srgbClr val="6B8299"/>
+                </a:solidFill>
+                <a:latin typeface="Segoe UI"/>
+              </a:rPr>
+              <a:t>contagem</a:t>
+            </a:r>
+            <a:r>
+              <a:rPr sz="600" b="0" dirty="0">
+                <a:solidFill>
+                  <a:srgbClr val="6B8299"/>
+                </a:solidFill>
+                <a:latin typeface="Segoe UI"/>
+              </a:rPr>
+              <a:t>, </a:t>
+            </a:r>
+            <a:r>
+              <a:rPr sz="600" b="0" dirty="0" err="1">
+                <a:solidFill>
+                  <a:srgbClr val="6B8299"/>
+                </a:solidFill>
+                <a:latin typeface="Segoe UI"/>
+              </a:rPr>
+              <a:t>linha</a:t>
+            </a:r>
+            <a:r>
+              <a:rPr sz="600" b="0" dirty="0">
+                <a:solidFill>
+                  <a:srgbClr val="6B8299"/>
+                </a:solidFill>
+                <a:latin typeface="Segoe UI"/>
+              </a:rPr>
+              <a:t> a </a:t>
+            </a:r>
+            <a:r>
+              <a:rPr sz="600" b="0" dirty="0" err="1">
+                <a:solidFill>
+                  <a:srgbClr val="6B8299"/>
+                </a:solidFill>
+                <a:latin typeface="Segoe UI"/>
+              </a:rPr>
+              <a:t>linha</a:t>
+            </a:r>
+            <a:r>
+              <a:rPr sz="600" b="0" dirty="0">
+                <a:solidFill>
+                  <a:srgbClr val="6B8299"/>
+                </a:solidFill>
+                <a:latin typeface="Segoe UI"/>
+              </a:rPr>
+              <a:t> </a:t>
+            </a:r>
+            <a:r>
+              <a:rPr sz="600" b="0" dirty="0" err="1">
+                <a:solidFill>
+                  <a:srgbClr val="6B8299"/>
+                </a:solidFill>
+                <a:latin typeface="Segoe UI"/>
+              </a:rPr>
+              <a:t>em</a:t>
+            </a:r>
+            <a:r>
+              <a:rPr sz="600" b="0" dirty="0">
+                <a:solidFill>
+                  <a:srgbClr val="6B8299"/>
+                </a:solidFill>
+                <a:latin typeface="Segoe UI"/>
+              </a:rPr>
+              <a:t> </a:t>
+            </a:r>
+            <a:r>
+              <a:rPr sz="600" b="0" dirty="0" err="1">
                 <a:solidFill>
                   <a:srgbClr val="9BAEC0"/>
                 </a:solidFill>
                 <a:latin typeface="Segoe UI"/>
               </a:rPr>
-              <a:t>classificacao_*.csv</a:t>
-            </a:r>
-            <a:r>
-              <a:rPr sz="600" b="0">
+              <a:t>classificacao</a:t>
+            </a:r>
+            <a:r>
+              <a:rPr sz="600" b="0" dirty="0">
+                <a:solidFill>
+                  <a:srgbClr val="9BAEC0"/>
+                </a:solidFill>
+                <a:latin typeface="Segoe UI"/>
+              </a:rPr>
+              <a:t>_*.csv</a:t>
+            </a:r>
+            <a:r>
+              <a:rPr sz="600" b="0" dirty="0">
                 <a:solidFill>
                   <a:srgbClr val="6B8299"/>
                 </a:solidFill>
@@ -10791,6 +11502,114 @@
               </a:rPr>
               <a:t>.</a:t>
             </a:r>
+          </a:p>
+        </p:txBody>
+      </p:sp>
+      <p:sp>
+        <p:nvSpPr>
+          <p:cNvPr id="49" name="TextBox 48"/>
+          <p:cNvSpPr txBox="1"/>
+          <p:nvPr/>
+        </p:nvSpPr>
+        <p:spPr>
+          <a:xfrm>
+            <a:off x="9363456" y="4626864"/>
+            <a:ext cx="1965960" cy="164592"/>
+          </a:xfrm>
+          <a:prstGeom prst="rect">
+            <a:avLst/>
+          </a:prstGeom>
+          <a:noFill/>
+        </p:spPr>
+        <p:txBody>
+          <a:bodyPr wrap="square" lIns="0" tIns="0" rIns="0" bIns="0" anchor="t">
+            <a:spAutoFit/>
+          </a:bodyPr>
+          <a:lstStyle/>
+          <a:p>
+            <a:pPr algn="l">
+              <a:lnSpc>
+                <a:spcPct val="125000"/>
+              </a:lnSpc>
+              <a:spcBef>
+                <a:spcPts val="0"/>
+              </a:spcBef>
+              <a:spcAft>
+                <a:spcPts val="0"/>
+              </a:spcAft>
+            </a:pPr>
+            <a:r>
+              <a:rPr sz="600" b="1" spc="100">
+                <a:solidFill>
+                  <a:srgbClr val="F5A623"/>
+                </a:solidFill>
+                <a:latin typeface="Segoe UI"/>
+              </a:rPr>
+              <a:t>FECHAMENTO</a:t>
+            </a:r>
+          </a:p>
+        </p:txBody>
+      </p:sp>
+      <p:sp>
+        <p:nvSpPr>
+          <p:cNvPr id="50" name="TextBox 49"/>
+          <p:cNvSpPr txBox="1"/>
+          <p:nvPr/>
+        </p:nvSpPr>
+        <p:spPr>
+          <a:xfrm>
+            <a:off x="9363456" y="4901184"/>
+            <a:ext cx="1965960" cy="1079655"/>
+          </a:xfrm>
+          <a:prstGeom prst="rect">
+            <a:avLst/>
+          </a:prstGeom>
+          <a:noFill/>
+        </p:spPr>
+        <p:txBody>
+          <a:bodyPr wrap="square" lIns="0" tIns="0" rIns="0" bIns="0" anchor="t">
+            <a:spAutoFit/>
+          </a:bodyPr>
+          <a:lstStyle/>
+          <a:p>
+            <a:pPr algn="just">
+              <a:lnSpc>
+                <a:spcPct val="118000"/>
+              </a:lnSpc>
+            </a:pPr>
+            <a:r>
+              <a:rPr lang="pt-BR" sz="600" dirty="0">
+                <a:solidFill>
+                  <a:srgbClr val="9BAEC0"/>
+                </a:solidFill>
+                <a:latin typeface="Segoe UI"/>
+              </a:rPr>
+              <a:t>Kairós não tenta prever o mercado — troca a opinião do gestor pelo preço de quem tem dinheiro em risco no desfecho. É o que torna a </a:t>
+            </a:r>
+            <a:r>
+              <a:rPr lang="pt-BR" sz="600" dirty="0" err="1">
+                <a:solidFill>
+                  <a:srgbClr val="9BAEC0"/>
+                </a:solidFill>
+                <a:latin typeface="Segoe UI"/>
+              </a:rPr>
+              <a:t>view</a:t>
+            </a:r>
+            <a:r>
+              <a:rPr lang="pt-BR" sz="600" dirty="0">
+                <a:solidFill>
+                  <a:srgbClr val="9BAEC0"/>
+                </a:solidFill>
+                <a:latin typeface="Segoe UI"/>
+              </a:rPr>
+              <a:t> auditável: Q e Ω deixam de ser declarados e passam a ser medidos, e o resultado passa a depender de acertar a probabilidade, não de escolher bem o parâmetro. Os +3,0 pp sobre o SPY ao mesmo risco saem daí — e de uma janela de alta, que é o limite honesto desta entrega. O que sustenta a tese não é a curva; é o que foi reprovado antes dela: 13 ideias medidas, uma entrou.</a:t>
+            </a:r>
+            <a:endParaRPr sz="600" b="0" dirty="0">
+              <a:solidFill>
+                <a:srgbClr val="9BAEC0"/>
+              </a:solidFill>
+              <a:latin typeface="Segoe UI"/>
+            </a:endParaRPr>
           </a:p>
         </p:txBody>
       </p:sp>

</xml_diff>